<commit_message>
add the contribution proportion to slide
</commit_message>
<xml_diff>
--- a/obesity_lifestyle_analysis.pptx
+++ b/obesity_lifestyle_analysis.pptx
@@ -5,7 +5,7 @@
     <p:sldMasterId id="2147483648" r:id="rId1"/>
   </p:sldMasterIdLst>
   <p:notesMasterIdLst>
-    <p:notesMasterId r:id="rId20"/>
+    <p:notesMasterId r:id="rId21"/>
   </p:notesMasterIdLst>
   <p:sldIdLst>
     <p:sldId id="256" r:id="rId2"/>
@@ -25,30 +25,35 @@
     <p:sldId id="264" r:id="rId16"/>
     <p:sldId id="265" r:id="rId17"/>
     <p:sldId id="266" r:id="rId18"/>
-    <p:sldId id="267" r:id="rId19"/>
+    <p:sldId id="275" r:id="rId19"/>
+    <p:sldId id="267" r:id="rId20"/>
   </p:sldIdLst>
   <p:sldSz cx="18288000" cy="10287000"/>
   <p:notesSz cx="6858000" cy="9144000"/>
   <p:embeddedFontLst>
     <p:embeddedFont>
       <p:font typeface="Aileron Bold" panose="020B0604020202020204" charset="0"/>
-      <p:regular r:id="rId21"/>
+      <p:regular r:id="rId22"/>
     </p:embeddedFont>
     <p:embeddedFont>
       <p:font typeface="Poppins" panose="00000500000000000000" pitchFamily="2" charset="0"/>
-      <p:regular r:id="rId22"/>
-      <p:bold r:id="rId23"/>
-      <p:italic r:id="rId24"/>
-      <p:boldItalic r:id="rId25"/>
+      <p:regular r:id="rId23"/>
+      <p:bold r:id="rId24"/>
+      <p:italic r:id="rId25"/>
+      <p:boldItalic r:id="rId26"/>
+    </p:embeddedFont>
+    <p:embeddedFont>
+      <p:font typeface="Poppins Black" panose="00000A00000000000000" pitchFamily="2" charset="0"/>
+      <p:bold r:id="rId27"/>
     </p:embeddedFont>
     <p:embeddedFont>
       <p:font typeface="Poppins Bold" panose="00000800000000000000" charset="0"/>
-      <p:regular r:id="rId26"/>
+      <p:regular r:id="rId28"/>
     </p:embeddedFont>
     <p:embeddedFont>
       <p:font typeface="Poppins Medium" panose="00000600000000000000" pitchFamily="2" charset="0"/>
-      <p:regular r:id="rId27"/>
-      <p:italic r:id="rId28"/>
+      <p:regular r:id="rId29"/>
+      <p:italic r:id="rId30"/>
     </p:embeddedFont>
   </p:embeddedFontLst>
   <p:defaultTextStyle>
@@ -247,7 +252,7 @@
           <a:p>
             <a:fld id="{E1FCFA53-D771-4F45-B5E4-B5E20C8ABC1C}" type="datetimeFigureOut">
               <a:rPr lang="en-US" smtClean="0"/>
-              <a:t>6/8/2026</a:t>
+              <a:t>6/9/2026</a:t>
             </a:fld>
             <a:endParaRPr lang="en-US"/>
           </a:p>
@@ -3750,7 +3755,7 @@
           <a:p>
             <a:fld id="{0DA97ACD-F630-4CE1-B4C0-0B07DA543432}" type="datetime1">
               <a:rPr lang="en-US" smtClean="0"/>
-              <a:t>6/8/2026</a:t>
+              <a:t>6/9/2026</a:t>
             </a:fld>
             <a:endParaRPr lang="en-US"/>
           </a:p>
@@ -3922,7 +3927,7 @@
           <a:p>
             <a:fld id="{21344191-4A96-4510-9597-D7E2F13E48AA}" type="datetime1">
               <a:rPr lang="en-US" smtClean="0"/>
-              <a:t>6/8/2026</a:t>
+              <a:t>6/9/2026</a:t>
             </a:fld>
             <a:endParaRPr lang="en-US"/>
           </a:p>
@@ -4104,7 +4109,7 @@
           <a:p>
             <a:fld id="{CC668943-383A-4824-A07A-7C67B3559D15}" type="datetime1">
               <a:rPr lang="en-US" smtClean="0"/>
-              <a:t>6/8/2026</a:t>
+              <a:t>6/9/2026</a:t>
             </a:fld>
             <a:endParaRPr lang="en-US"/>
           </a:p>
@@ -4276,7 +4281,7 @@
           <a:p>
             <a:fld id="{CE6880CE-6FC8-41F6-A80B-D416914C5154}" type="datetime1">
               <a:rPr lang="en-US" smtClean="0"/>
-              <a:t>6/8/2026</a:t>
+              <a:t>6/9/2026</a:t>
             </a:fld>
             <a:endParaRPr lang="en-US"/>
           </a:p>
@@ -4525,7 +4530,7 @@
           <a:p>
             <a:fld id="{2BFA1AD8-C322-4D9D-B1F5-16E06D9E6838}" type="datetime1">
               <a:rPr lang="en-US" smtClean="0"/>
-              <a:t>6/8/2026</a:t>
+              <a:t>6/9/2026</a:t>
             </a:fld>
             <a:endParaRPr lang="en-US"/>
           </a:p>
@@ -4814,7 +4819,7 @@
           <a:p>
             <a:fld id="{38668542-C8BD-4EFA-B143-FB2E9536377D}" type="datetime1">
               <a:rPr lang="en-US" smtClean="0"/>
-              <a:t>6/8/2026</a:t>
+              <a:t>6/9/2026</a:t>
             </a:fld>
             <a:endParaRPr lang="en-US"/>
           </a:p>
@@ -5237,7 +5242,7 @@
           <a:p>
             <a:fld id="{F79FD5DC-122B-4FA4-A25A-7B0FF1D1F533}" type="datetime1">
               <a:rPr lang="en-US" smtClean="0"/>
-              <a:t>6/8/2026</a:t>
+              <a:t>6/9/2026</a:t>
             </a:fld>
             <a:endParaRPr lang="en-US"/>
           </a:p>
@@ -5358,7 +5363,7 @@
           <a:p>
             <a:fld id="{3FF87746-6C8F-4D1E-A4DA-69DA27ECB947}" type="datetime1">
               <a:rPr lang="en-US" smtClean="0"/>
-              <a:t>6/8/2026</a:t>
+              <a:t>6/9/2026</a:t>
             </a:fld>
             <a:endParaRPr lang="en-US"/>
           </a:p>
@@ -5457,7 +5462,7 @@
           <a:p>
             <a:fld id="{AD1A4A9E-DD74-4D97-84EE-7ACE4DDB1CD6}" type="datetime1">
               <a:rPr lang="en-US" smtClean="0"/>
-              <a:t>6/8/2026</a:t>
+              <a:t>6/9/2026</a:t>
             </a:fld>
             <a:endParaRPr lang="en-US"/>
           </a:p>
@@ -5749,7 +5754,7 @@
           <a:p>
             <a:fld id="{A7F18E67-D0EA-4FE9-B781-B24CF76730A4}" type="datetime1">
               <a:rPr lang="en-US" smtClean="0"/>
-              <a:t>6/8/2026</a:t>
+              <a:t>6/9/2026</a:t>
             </a:fld>
             <a:endParaRPr lang="en-US"/>
           </a:p>
@@ -6005,7 +6010,7 @@
           <a:p>
             <a:fld id="{527D3AB8-C437-45E0-8127-5964A477AD4D}" type="datetime1">
               <a:rPr lang="en-US" smtClean="0"/>
-              <a:t>6/8/2026</a:t>
+              <a:t>6/9/2026</a:t>
             </a:fld>
             <a:endParaRPr lang="en-US"/>
           </a:p>
@@ -11289,13 +11294,13 @@
   <p:clrMapOvr>
     <a:masterClrMapping/>
   </p:clrMapOvr>
-  <mc:AlternateContent xmlns:mc="http://schemas.openxmlformats.org/markup-compatibility/2006">
-    <mc:Choice xmlns:p159="http://schemas.microsoft.com/office/powerpoint/2015/09/main" Requires="p159">
+  <mc:AlternateContent xmlns:mc="http://schemas.openxmlformats.org/markup-compatibility/2006" xmlns:p159="http://schemas.microsoft.com/office/powerpoint/2015/09/main">
+    <mc:Choice Requires="p159">
       <p:transition xmlns:p14="http://schemas.microsoft.com/office/powerpoint/2010/main" spd="slow" p14:dur="2000">
         <p159:morph option="byObject"/>
       </p:transition>
     </mc:Choice>
-    <mc:Fallback>
+    <mc:Fallback xmlns="">
       <p:transition spd="slow">
         <p:fade/>
       </p:transition>
@@ -12307,13 +12312,13 @@
   <p:clrMapOvr>
     <a:masterClrMapping/>
   </p:clrMapOvr>
-  <mc:AlternateContent xmlns:mc="http://schemas.openxmlformats.org/markup-compatibility/2006">
-    <mc:Choice xmlns:p159="http://schemas.microsoft.com/office/powerpoint/2015/09/main" Requires="p159">
+  <mc:AlternateContent xmlns:mc="http://schemas.openxmlformats.org/markup-compatibility/2006" xmlns:p159="http://schemas.microsoft.com/office/powerpoint/2015/09/main">
+    <mc:Choice Requires="p159">
       <p:transition xmlns:p14="http://schemas.microsoft.com/office/powerpoint/2010/main" spd="slow" p14:dur="2000">
         <p159:morph option="byObject"/>
       </p:transition>
     </mc:Choice>
-    <mc:Fallback>
+    <mc:Fallback xmlns="">
       <p:transition spd="slow">
         <p:fade/>
       </p:transition>
@@ -14704,6 +14709,2063 @@
 </file>
 
 <file path=ppt/slides/slide18.xml><?xml version="1.0" encoding="utf-8"?>
+<p:sld xmlns:a="http://schemas.openxmlformats.org/drawingml/2006/main" xmlns:r="http://schemas.openxmlformats.org/officeDocument/2006/relationships" xmlns:p="http://schemas.openxmlformats.org/presentationml/2006/main">
+  <p:cSld>
+    <p:spTree>
+      <p:nvGrpSpPr>
+        <p:cNvPr id="1" name="">
+          <a:extLst>
+            <a:ext uri="{FF2B5EF4-FFF2-40B4-BE49-F238E27FC236}">
+              <a16:creationId xmlns:a16="http://schemas.microsoft.com/office/drawing/2014/main" id="{00DFE122-9153-A6D0-9FBF-D249C189BA9B}"/>
+            </a:ext>
+          </a:extLst>
+        </p:cNvPr>
+        <p:cNvGrpSpPr/>
+        <p:nvPr/>
+      </p:nvGrpSpPr>
+      <p:grpSpPr>
+        <a:xfrm>
+          <a:off x="0" y="0"/>
+          <a:ext cx="0" cy="0"/>
+          <a:chOff x="0" y="0"/>
+          <a:chExt cx="0" cy="0"/>
+        </a:xfrm>
+      </p:grpSpPr>
+      <p:grpSp>
+        <p:nvGrpSpPr>
+          <p:cNvPr id="36" name="Group 35">
+            <a:extLst>
+              <a:ext uri="{FF2B5EF4-FFF2-40B4-BE49-F238E27FC236}">
+                <a16:creationId xmlns:a16="http://schemas.microsoft.com/office/drawing/2014/main" id="{0506ACBD-B82C-9549-E9C7-3578CC4BF99A}"/>
+              </a:ext>
+            </a:extLst>
+          </p:cNvPr>
+          <p:cNvGrpSpPr/>
+          <p:nvPr/>
+        </p:nvGrpSpPr>
+        <p:grpSpPr>
+          <a:xfrm>
+            <a:off x="4191284" y="259167"/>
+            <a:ext cx="9905432" cy="812910"/>
+            <a:chOff x="3513325" y="6141835"/>
+            <a:chExt cx="9905432" cy="812910"/>
+          </a:xfrm>
+        </p:grpSpPr>
+        <p:grpSp>
+          <p:nvGrpSpPr>
+            <p:cNvPr id="3" name="Group 3">
+              <a:extLst>
+                <a:ext uri="{FF2B5EF4-FFF2-40B4-BE49-F238E27FC236}">
+                  <a16:creationId xmlns:a16="http://schemas.microsoft.com/office/drawing/2014/main" id="{68EB7257-498F-A866-6F97-30E4D26EA463}"/>
+                </a:ext>
+              </a:extLst>
+            </p:cNvPr>
+            <p:cNvGrpSpPr/>
+            <p:nvPr/>
+          </p:nvGrpSpPr>
+          <p:grpSpPr>
+            <a:xfrm>
+              <a:off x="4623159" y="6141835"/>
+              <a:ext cx="8795598" cy="812910"/>
+              <a:chOff x="0" y="0"/>
+              <a:chExt cx="2108811" cy="194901"/>
+            </a:xfrm>
+          </p:grpSpPr>
+          <p:sp>
+            <p:nvSpPr>
+              <p:cNvPr id="4" name="Freeform 4">
+                <a:extLst>
+                  <a:ext uri="{FF2B5EF4-FFF2-40B4-BE49-F238E27FC236}">
+                    <a16:creationId xmlns:a16="http://schemas.microsoft.com/office/drawing/2014/main" id="{39B83FCD-825E-3431-C604-2B3CF5D01DEC}"/>
+                  </a:ext>
+                </a:extLst>
+              </p:cNvPr>
+              <p:cNvSpPr/>
+              <p:nvPr/>
+            </p:nvSpPr>
+            <p:spPr>
+              <a:xfrm>
+                <a:off x="0" y="0"/>
+                <a:ext cx="2108811" cy="194901"/>
+              </a:xfrm>
+              <a:custGeom>
+                <a:avLst/>
+                <a:gdLst/>
+                <a:ahLst/>
+                <a:cxnLst/>
+                <a:rect l="l" t="t" r="r" b="b"/>
+                <a:pathLst>
+                  <a:path w="2108811" h="194901">
+                    <a:moveTo>
+                      <a:pt x="88020" y="0"/>
+                    </a:moveTo>
+                    <a:lnTo>
+                      <a:pt x="2020791" y="0"/>
+                    </a:lnTo>
+                    <a:cubicBezTo>
+                      <a:pt x="2069403" y="0"/>
+                      <a:pt x="2108811" y="39408"/>
+                      <a:pt x="2108811" y="88020"/>
+                    </a:cubicBezTo>
+                    <a:lnTo>
+                      <a:pt x="2108811" y="106881"/>
+                    </a:lnTo>
+                    <a:cubicBezTo>
+                      <a:pt x="2108811" y="155493"/>
+                      <a:pt x="2069403" y="194901"/>
+                      <a:pt x="2020791" y="194901"/>
+                    </a:cubicBezTo>
+                    <a:lnTo>
+                      <a:pt x="88020" y="194901"/>
+                    </a:lnTo>
+                    <a:cubicBezTo>
+                      <a:pt x="39408" y="194901"/>
+                      <a:pt x="0" y="155493"/>
+                      <a:pt x="0" y="106881"/>
+                    </a:cubicBezTo>
+                    <a:lnTo>
+                      <a:pt x="0" y="88020"/>
+                    </a:lnTo>
+                    <a:cubicBezTo>
+                      <a:pt x="0" y="39408"/>
+                      <a:pt x="39408" y="0"/>
+                      <a:pt x="88020" y="0"/>
+                    </a:cubicBezTo>
+                    <a:close/>
+                  </a:path>
+                </a:pathLst>
+              </a:custGeom>
+              <a:gradFill rotWithShape="1">
+                <a:gsLst>
+                  <a:gs pos="0">
+                    <a:srgbClr val="398DFA">
+                      <a:alpha val="60000"/>
+                    </a:srgbClr>
+                  </a:gs>
+                  <a:gs pos="50000">
+                    <a:srgbClr val="0151B8">
+                      <a:alpha val="14400"/>
+                    </a:srgbClr>
+                  </a:gs>
+                  <a:gs pos="100000">
+                    <a:srgbClr val="0151B8">
+                      <a:alpha val="0"/>
+                    </a:srgbClr>
+                  </a:gs>
+                </a:gsLst>
+                <a:lin ang="0"/>
+              </a:gradFill>
+            </p:spPr>
+            <p:txBody>
+              <a:bodyPr/>
+              <a:lstStyle/>
+              <a:p>
+                <a:endParaRPr lang="en-US"/>
+              </a:p>
+            </p:txBody>
+          </p:sp>
+          <p:sp>
+            <p:nvSpPr>
+              <p:cNvPr id="5" name="TextBox 5">
+                <a:extLst>
+                  <a:ext uri="{FF2B5EF4-FFF2-40B4-BE49-F238E27FC236}">
+                    <a16:creationId xmlns:a16="http://schemas.microsoft.com/office/drawing/2014/main" id="{263405FF-0E48-3038-9097-AE25AFA18456}"/>
+                  </a:ext>
+                </a:extLst>
+              </p:cNvPr>
+              <p:cNvSpPr txBox="1"/>
+              <p:nvPr/>
+            </p:nvSpPr>
+            <p:spPr>
+              <a:xfrm>
+                <a:off x="0" y="-38100"/>
+                <a:ext cx="2108811" cy="233001"/>
+              </a:xfrm>
+              <a:prstGeom prst="rect">
+                <a:avLst/>
+              </a:prstGeom>
+            </p:spPr>
+            <p:txBody>
+              <a:bodyPr lIns="50800" tIns="50800" rIns="50800" bIns="50800" rtlCol="0" anchor="ctr"/>
+              <a:lstStyle/>
+              <a:p>
+                <a:pPr algn="ctr">
+                  <a:lnSpc>
+                    <a:spcPts val="2659"/>
+                  </a:lnSpc>
+                  <a:spcBef>
+                    <a:spcPct val="0"/>
+                  </a:spcBef>
+                </a:pPr>
+                <a:endParaRPr/>
+              </a:p>
+            </p:txBody>
+          </p:sp>
+        </p:grpSp>
+        <p:sp>
+          <p:nvSpPr>
+            <p:cNvPr id="6" name="TextBox 6">
+              <a:extLst>
+                <a:ext uri="{FF2B5EF4-FFF2-40B4-BE49-F238E27FC236}">
+                  <a16:creationId xmlns:a16="http://schemas.microsoft.com/office/drawing/2014/main" id="{A2FADC79-FE4E-0676-A622-B45BCF5DB3E9}"/>
+                </a:ext>
+              </a:extLst>
+            </p:cNvPr>
+            <p:cNvSpPr txBox="1"/>
+            <p:nvPr/>
+          </p:nvSpPr>
+          <p:spPr>
+            <a:xfrm>
+              <a:off x="3513325" y="6190654"/>
+              <a:ext cx="9448490" cy="583942"/>
+            </a:xfrm>
+            <a:prstGeom prst="rect">
+              <a:avLst/>
+            </a:prstGeom>
+          </p:spPr>
+          <p:txBody>
+            <a:bodyPr lIns="0" tIns="0" rIns="0" bIns="0" rtlCol="0" anchor="t">
+              <a:spAutoFit/>
+            </a:bodyPr>
+            <a:lstStyle/>
+            <a:p>
+              <a:pPr algn="ctr">
+                <a:lnSpc>
+                  <a:spcPts val="4767"/>
+                </a:lnSpc>
+                <a:spcBef>
+                  <a:spcPct val="0"/>
+                </a:spcBef>
+              </a:pPr>
+              <a:r>
+                <a:rPr lang="en-US" sz="3000">
+                  <a:solidFill>
+                    <a:srgbClr val="000000"/>
+                  </a:solidFill>
+                  <a:latin typeface="Poppins Black" panose="00000A00000000000000" pitchFamily="2" charset="0"/>
+                  <a:ea typeface="Poppins"/>
+                  <a:cs typeface="Poppins Black" panose="00000A00000000000000" pitchFamily="2" charset="0"/>
+                  <a:sym typeface="Poppins"/>
+                </a:rPr>
+                <a:t>Contributions</a:t>
+              </a:r>
+            </a:p>
+          </p:txBody>
+        </p:sp>
+      </p:grpSp>
+      <p:grpSp>
+        <p:nvGrpSpPr>
+          <p:cNvPr id="7" name="Group 7">
+            <a:extLst>
+              <a:ext uri="{FF2B5EF4-FFF2-40B4-BE49-F238E27FC236}">
+                <a16:creationId xmlns:a16="http://schemas.microsoft.com/office/drawing/2014/main" id="{47BF68B5-C34E-03ED-3788-FA8D10FC4EFF}"/>
+              </a:ext>
+            </a:extLst>
+          </p:cNvPr>
+          <p:cNvGrpSpPr/>
+          <p:nvPr/>
+        </p:nvGrpSpPr>
+        <p:grpSpPr>
+          <a:xfrm rot="9689905">
+            <a:off x="16976943" y="3243375"/>
+            <a:ext cx="5289783" cy="5289783"/>
+            <a:chOff x="0" y="0"/>
+            <a:chExt cx="812800" cy="812800"/>
+          </a:xfrm>
+        </p:grpSpPr>
+        <p:sp>
+          <p:nvSpPr>
+            <p:cNvPr id="8" name="Freeform 8">
+              <a:extLst>
+                <a:ext uri="{FF2B5EF4-FFF2-40B4-BE49-F238E27FC236}">
+                  <a16:creationId xmlns:a16="http://schemas.microsoft.com/office/drawing/2014/main" id="{491A31DC-A7A5-EEC1-6FDA-217BEE64F0AA}"/>
+                </a:ext>
+              </a:extLst>
+            </p:cNvPr>
+            <p:cNvSpPr/>
+            <p:nvPr/>
+          </p:nvSpPr>
+          <p:spPr>
+            <a:xfrm>
+              <a:off x="0" y="0"/>
+              <a:ext cx="812800" cy="812800"/>
+            </a:xfrm>
+            <a:custGeom>
+              <a:avLst/>
+              <a:gdLst/>
+              <a:ahLst/>
+              <a:cxnLst/>
+              <a:rect l="l" t="t" r="r" b="b"/>
+              <a:pathLst>
+                <a:path w="812800" h="812800">
+                  <a:moveTo>
+                    <a:pt x="406400" y="0"/>
+                  </a:moveTo>
+                  <a:cubicBezTo>
+                    <a:pt x="181951" y="0"/>
+                    <a:pt x="0" y="181951"/>
+                    <a:pt x="0" y="406400"/>
+                  </a:cubicBezTo>
+                  <a:cubicBezTo>
+                    <a:pt x="0" y="630849"/>
+                    <a:pt x="181951" y="812800"/>
+                    <a:pt x="406400" y="812800"/>
+                  </a:cubicBezTo>
+                  <a:cubicBezTo>
+                    <a:pt x="630849" y="812800"/>
+                    <a:pt x="812800" y="630849"/>
+                    <a:pt x="812800" y="406400"/>
+                  </a:cubicBezTo>
+                  <a:cubicBezTo>
+                    <a:pt x="812800" y="181951"/>
+                    <a:pt x="630849" y="0"/>
+                    <a:pt x="406400" y="0"/>
+                  </a:cubicBezTo>
+                  <a:close/>
+                </a:path>
+              </a:pathLst>
+            </a:custGeom>
+            <a:gradFill rotWithShape="1">
+              <a:gsLst>
+                <a:gs pos="0">
+                  <a:srgbClr val="0151B8">
+                    <a:alpha val="100000"/>
+                  </a:srgbClr>
+                </a:gs>
+                <a:gs pos="50000">
+                  <a:srgbClr val="0151B8">
+                    <a:alpha val="24000"/>
+                  </a:srgbClr>
+                </a:gs>
+                <a:gs pos="100000">
+                  <a:srgbClr val="0151B8">
+                    <a:alpha val="0"/>
+                  </a:srgbClr>
+                </a:gs>
+              </a:gsLst>
+              <a:lin ang="0"/>
+            </a:gradFill>
+            <a:ln cap="sq">
+              <a:noFill/>
+              <a:prstDash val="solid"/>
+              <a:miter/>
+            </a:ln>
+          </p:spPr>
+          <p:txBody>
+            <a:bodyPr/>
+            <a:lstStyle/>
+            <a:p>
+              <a:endParaRPr lang="en-US"/>
+            </a:p>
+          </p:txBody>
+        </p:sp>
+        <p:sp>
+          <p:nvSpPr>
+            <p:cNvPr id="9" name="TextBox 9">
+              <a:extLst>
+                <a:ext uri="{FF2B5EF4-FFF2-40B4-BE49-F238E27FC236}">
+                  <a16:creationId xmlns:a16="http://schemas.microsoft.com/office/drawing/2014/main" id="{713656C3-64E9-F91B-D5E6-6D82B54E0BD6}"/>
+                </a:ext>
+              </a:extLst>
+            </p:cNvPr>
+            <p:cNvSpPr txBox="1"/>
+            <p:nvPr/>
+          </p:nvSpPr>
+          <p:spPr>
+            <a:xfrm>
+              <a:off x="76200" y="38100"/>
+              <a:ext cx="660400" cy="698500"/>
+            </a:xfrm>
+            <a:prstGeom prst="rect">
+              <a:avLst/>
+            </a:prstGeom>
+          </p:spPr>
+          <p:txBody>
+            <a:bodyPr lIns="50800" tIns="50800" rIns="50800" bIns="50800" rtlCol="0" anchor="ctr"/>
+            <a:lstStyle/>
+            <a:p>
+              <a:pPr marL="0" lvl="0" indent="0" algn="ctr">
+                <a:lnSpc>
+                  <a:spcPts val="2659"/>
+                </a:lnSpc>
+                <a:spcBef>
+                  <a:spcPct val="0"/>
+                </a:spcBef>
+              </a:pPr>
+              <a:endParaRPr/>
+            </a:p>
+          </p:txBody>
+        </p:sp>
+      </p:grpSp>
+      <p:grpSp>
+        <p:nvGrpSpPr>
+          <p:cNvPr id="10" name="Group 10">
+            <a:extLst>
+              <a:ext uri="{FF2B5EF4-FFF2-40B4-BE49-F238E27FC236}">
+                <a16:creationId xmlns:a16="http://schemas.microsoft.com/office/drawing/2014/main" id="{6889D446-85D1-F57A-2257-83179B3F000A}"/>
+              </a:ext>
+            </a:extLst>
+          </p:cNvPr>
+          <p:cNvGrpSpPr/>
+          <p:nvPr/>
+        </p:nvGrpSpPr>
+        <p:grpSpPr>
+          <a:xfrm rot="1587174">
+            <a:off x="-3346379" y="1209267"/>
+            <a:ext cx="5289783" cy="5289783"/>
+            <a:chOff x="0" y="0"/>
+            <a:chExt cx="812800" cy="812800"/>
+          </a:xfrm>
+        </p:grpSpPr>
+        <p:sp>
+          <p:nvSpPr>
+            <p:cNvPr id="11" name="Freeform 11">
+              <a:extLst>
+                <a:ext uri="{FF2B5EF4-FFF2-40B4-BE49-F238E27FC236}">
+                  <a16:creationId xmlns:a16="http://schemas.microsoft.com/office/drawing/2014/main" id="{0CB4E5AA-6426-251D-A4E8-EBF3845C7A0B}"/>
+                </a:ext>
+              </a:extLst>
+            </p:cNvPr>
+            <p:cNvSpPr/>
+            <p:nvPr/>
+          </p:nvSpPr>
+          <p:spPr>
+            <a:xfrm>
+              <a:off x="0" y="0"/>
+              <a:ext cx="812800" cy="812800"/>
+            </a:xfrm>
+            <a:custGeom>
+              <a:avLst/>
+              <a:gdLst/>
+              <a:ahLst/>
+              <a:cxnLst/>
+              <a:rect l="l" t="t" r="r" b="b"/>
+              <a:pathLst>
+                <a:path w="812800" h="812800">
+                  <a:moveTo>
+                    <a:pt x="406400" y="0"/>
+                  </a:moveTo>
+                  <a:cubicBezTo>
+                    <a:pt x="181951" y="0"/>
+                    <a:pt x="0" y="181951"/>
+                    <a:pt x="0" y="406400"/>
+                  </a:cubicBezTo>
+                  <a:cubicBezTo>
+                    <a:pt x="0" y="630849"/>
+                    <a:pt x="181951" y="812800"/>
+                    <a:pt x="406400" y="812800"/>
+                  </a:cubicBezTo>
+                  <a:cubicBezTo>
+                    <a:pt x="630849" y="812800"/>
+                    <a:pt x="812800" y="630849"/>
+                    <a:pt x="812800" y="406400"/>
+                  </a:cubicBezTo>
+                  <a:cubicBezTo>
+                    <a:pt x="812800" y="181951"/>
+                    <a:pt x="630849" y="0"/>
+                    <a:pt x="406400" y="0"/>
+                  </a:cubicBezTo>
+                  <a:close/>
+                </a:path>
+              </a:pathLst>
+            </a:custGeom>
+            <a:gradFill rotWithShape="1">
+              <a:gsLst>
+                <a:gs pos="0">
+                  <a:srgbClr val="0151B8">
+                    <a:alpha val="100000"/>
+                  </a:srgbClr>
+                </a:gs>
+                <a:gs pos="50000">
+                  <a:srgbClr val="0151B8">
+                    <a:alpha val="24000"/>
+                  </a:srgbClr>
+                </a:gs>
+                <a:gs pos="100000">
+                  <a:srgbClr val="0151B8">
+                    <a:alpha val="0"/>
+                  </a:srgbClr>
+                </a:gs>
+              </a:gsLst>
+              <a:lin ang="0"/>
+            </a:gradFill>
+            <a:ln cap="sq">
+              <a:noFill/>
+              <a:prstDash val="solid"/>
+              <a:miter/>
+            </a:ln>
+          </p:spPr>
+          <p:txBody>
+            <a:bodyPr/>
+            <a:lstStyle/>
+            <a:p>
+              <a:endParaRPr lang="en-US"/>
+            </a:p>
+          </p:txBody>
+        </p:sp>
+        <p:sp>
+          <p:nvSpPr>
+            <p:cNvPr id="12" name="TextBox 12">
+              <a:extLst>
+                <a:ext uri="{FF2B5EF4-FFF2-40B4-BE49-F238E27FC236}">
+                  <a16:creationId xmlns:a16="http://schemas.microsoft.com/office/drawing/2014/main" id="{597050FA-5945-3873-C37C-D12BCC009480}"/>
+                </a:ext>
+              </a:extLst>
+            </p:cNvPr>
+            <p:cNvSpPr txBox="1"/>
+            <p:nvPr/>
+          </p:nvSpPr>
+          <p:spPr>
+            <a:xfrm>
+              <a:off x="76200" y="38100"/>
+              <a:ext cx="660400" cy="698500"/>
+            </a:xfrm>
+            <a:prstGeom prst="rect">
+              <a:avLst/>
+            </a:prstGeom>
+          </p:spPr>
+          <p:txBody>
+            <a:bodyPr lIns="50800" tIns="50800" rIns="50800" bIns="50800" rtlCol="0" anchor="ctr"/>
+            <a:lstStyle/>
+            <a:p>
+              <a:pPr marL="0" lvl="0" indent="0" algn="ctr">
+                <a:lnSpc>
+                  <a:spcPts val="2659"/>
+                </a:lnSpc>
+                <a:spcBef>
+                  <a:spcPct val="0"/>
+                </a:spcBef>
+              </a:pPr>
+              <a:endParaRPr/>
+            </a:p>
+          </p:txBody>
+        </p:sp>
+      </p:grpSp>
+      <p:grpSp>
+        <p:nvGrpSpPr>
+          <p:cNvPr id="13" name="Group 13">
+            <a:extLst>
+              <a:ext uri="{FF2B5EF4-FFF2-40B4-BE49-F238E27FC236}">
+                <a16:creationId xmlns:a16="http://schemas.microsoft.com/office/drawing/2014/main" id="{E82CC467-7041-7873-579F-CE6695FF92B8}"/>
+              </a:ext>
+            </a:extLst>
+          </p:cNvPr>
+          <p:cNvGrpSpPr/>
+          <p:nvPr/>
+        </p:nvGrpSpPr>
+        <p:grpSpPr>
+          <a:xfrm>
+            <a:off x="16100875" y="259167"/>
+            <a:ext cx="1384678" cy="1384678"/>
+            <a:chOff x="0" y="0"/>
+            <a:chExt cx="812800" cy="812800"/>
+          </a:xfrm>
+        </p:grpSpPr>
+        <p:sp>
+          <p:nvSpPr>
+            <p:cNvPr id="14" name="Freeform 14">
+              <a:extLst>
+                <a:ext uri="{FF2B5EF4-FFF2-40B4-BE49-F238E27FC236}">
+                  <a16:creationId xmlns:a16="http://schemas.microsoft.com/office/drawing/2014/main" id="{21DD6A2E-ED8E-1B2C-F771-127DE8790176}"/>
+                </a:ext>
+              </a:extLst>
+            </p:cNvPr>
+            <p:cNvSpPr/>
+            <p:nvPr/>
+          </p:nvSpPr>
+          <p:spPr>
+            <a:xfrm>
+              <a:off x="0" y="0"/>
+              <a:ext cx="812800" cy="812800"/>
+            </a:xfrm>
+            <a:custGeom>
+              <a:avLst/>
+              <a:gdLst/>
+              <a:ahLst/>
+              <a:cxnLst/>
+              <a:rect l="l" t="t" r="r" b="b"/>
+              <a:pathLst>
+                <a:path w="812800" h="812800">
+                  <a:moveTo>
+                    <a:pt x="406400" y="0"/>
+                  </a:moveTo>
+                  <a:cubicBezTo>
+                    <a:pt x="181951" y="0"/>
+                    <a:pt x="0" y="181951"/>
+                    <a:pt x="0" y="406400"/>
+                  </a:cubicBezTo>
+                  <a:cubicBezTo>
+                    <a:pt x="0" y="630849"/>
+                    <a:pt x="181951" y="812800"/>
+                    <a:pt x="406400" y="812800"/>
+                  </a:cubicBezTo>
+                  <a:cubicBezTo>
+                    <a:pt x="630849" y="812800"/>
+                    <a:pt x="812800" y="630849"/>
+                    <a:pt x="812800" y="406400"/>
+                  </a:cubicBezTo>
+                  <a:cubicBezTo>
+                    <a:pt x="812800" y="181951"/>
+                    <a:pt x="630849" y="0"/>
+                    <a:pt x="406400" y="0"/>
+                  </a:cubicBezTo>
+                  <a:close/>
+                </a:path>
+              </a:pathLst>
+            </a:custGeom>
+            <a:gradFill rotWithShape="1">
+              <a:gsLst>
+                <a:gs pos="0">
+                  <a:srgbClr val="0151B8">
+                    <a:alpha val="100000"/>
+                  </a:srgbClr>
+                </a:gs>
+                <a:gs pos="100000">
+                  <a:srgbClr val="0151B8">
+                    <a:alpha val="24000"/>
+                  </a:srgbClr>
+                </a:gs>
+              </a:gsLst>
+              <a:lin ang="0"/>
+            </a:gradFill>
+            <a:ln cap="sq">
+              <a:noFill/>
+              <a:prstDash val="solid"/>
+              <a:miter/>
+            </a:ln>
+          </p:spPr>
+          <p:txBody>
+            <a:bodyPr/>
+            <a:lstStyle/>
+            <a:p>
+              <a:endParaRPr lang="en-US"/>
+            </a:p>
+          </p:txBody>
+        </p:sp>
+        <p:sp>
+          <p:nvSpPr>
+            <p:cNvPr id="15" name="TextBox 15">
+              <a:extLst>
+                <a:ext uri="{FF2B5EF4-FFF2-40B4-BE49-F238E27FC236}">
+                  <a16:creationId xmlns:a16="http://schemas.microsoft.com/office/drawing/2014/main" id="{E1D2F021-EE9C-F50A-9881-F38187556FC6}"/>
+                </a:ext>
+              </a:extLst>
+            </p:cNvPr>
+            <p:cNvSpPr txBox="1"/>
+            <p:nvPr/>
+          </p:nvSpPr>
+          <p:spPr>
+            <a:xfrm>
+              <a:off x="76200" y="38100"/>
+              <a:ext cx="660400" cy="698500"/>
+            </a:xfrm>
+            <a:prstGeom prst="rect">
+              <a:avLst/>
+            </a:prstGeom>
+          </p:spPr>
+          <p:txBody>
+            <a:bodyPr lIns="50800" tIns="50800" rIns="50800" bIns="50800" rtlCol="0" anchor="ctr"/>
+            <a:lstStyle/>
+            <a:p>
+              <a:pPr marL="0" lvl="0" indent="0" algn="ctr">
+                <a:lnSpc>
+                  <a:spcPts val="2659"/>
+                </a:lnSpc>
+                <a:spcBef>
+                  <a:spcPct val="0"/>
+                </a:spcBef>
+              </a:pPr>
+              <a:endParaRPr/>
+            </a:p>
+          </p:txBody>
+        </p:sp>
+      </p:grpSp>
+      <p:grpSp>
+        <p:nvGrpSpPr>
+          <p:cNvPr id="16" name="Group 16">
+            <a:extLst>
+              <a:ext uri="{FF2B5EF4-FFF2-40B4-BE49-F238E27FC236}">
+                <a16:creationId xmlns:a16="http://schemas.microsoft.com/office/drawing/2014/main" id="{E5A2F203-FAAF-3132-5670-07E9448C42FC}"/>
+              </a:ext>
+            </a:extLst>
+          </p:cNvPr>
+          <p:cNvGrpSpPr/>
+          <p:nvPr/>
+        </p:nvGrpSpPr>
+        <p:grpSpPr>
+          <a:xfrm>
+            <a:off x="761729" y="6243643"/>
+            <a:ext cx="1384678" cy="1384678"/>
+            <a:chOff x="0" y="0"/>
+            <a:chExt cx="812800" cy="812800"/>
+          </a:xfrm>
+        </p:grpSpPr>
+        <p:sp>
+          <p:nvSpPr>
+            <p:cNvPr id="17" name="Freeform 17">
+              <a:extLst>
+                <a:ext uri="{FF2B5EF4-FFF2-40B4-BE49-F238E27FC236}">
+                  <a16:creationId xmlns:a16="http://schemas.microsoft.com/office/drawing/2014/main" id="{996FF6D5-6185-5E24-66E2-6D2F350A1F23}"/>
+                </a:ext>
+              </a:extLst>
+            </p:cNvPr>
+            <p:cNvSpPr/>
+            <p:nvPr/>
+          </p:nvSpPr>
+          <p:spPr>
+            <a:xfrm>
+              <a:off x="0" y="0"/>
+              <a:ext cx="812800" cy="812800"/>
+            </a:xfrm>
+            <a:custGeom>
+              <a:avLst/>
+              <a:gdLst/>
+              <a:ahLst/>
+              <a:cxnLst/>
+              <a:rect l="l" t="t" r="r" b="b"/>
+              <a:pathLst>
+                <a:path w="812800" h="812800">
+                  <a:moveTo>
+                    <a:pt x="406400" y="0"/>
+                  </a:moveTo>
+                  <a:cubicBezTo>
+                    <a:pt x="181951" y="0"/>
+                    <a:pt x="0" y="181951"/>
+                    <a:pt x="0" y="406400"/>
+                  </a:cubicBezTo>
+                  <a:cubicBezTo>
+                    <a:pt x="0" y="630849"/>
+                    <a:pt x="181951" y="812800"/>
+                    <a:pt x="406400" y="812800"/>
+                  </a:cubicBezTo>
+                  <a:cubicBezTo>
+                    <a:pt x="630849" y="812800"/>
+                    <a:pt x="812800" y="630849"/>
+                    <a:pt x="812800" y="406400"/>
+                  </a:cubicBezTo>
+                  <a:cubicBezTo>
+                    <a:pt x="812800" y="181951"/>
+                    <a:pt x="630849" y="0"/>
+                    <a:pt x="406400" y="0"/>
+                  </a:cubicBezTo>
+                  <a:close/>
+                </a:path>
+              </a:pathLst>
+            </a:custGeom>
+            <a:gradFill rotWithShape="1">
+              <a:gsLst>
+                <a:gs pos="0">
+                  <a:srgbClr val="0151B8">
+                    <a:alpha val="100000"/>
+                  </a:srgbClr>
+                </a:gs>
+                <a:gs pos="100000">
+                  <a:srgbClr val="0151B8">
+                    <a:alpha val="24000"/>
+                  </a:srgbClr>
+                </a:gs>
+              </a:gsLst>
+              <a:lin ang="0"/>
+            </a:gradFill>
+            <a:ln cap="sq">
+              <a:noFill/>
+              <a:prstDash val="solid"/>
+              <a:miter/>
+            </a:ln>
+          </p:spPr>
+          <p:txBody>
+            <a:bodyPr/>
+            <a:lstStyle/>
+            <a:p>
+              <a:endParaRPr lang="en-US"/>
+            </a:p>
+          </p:txBody>
+        </p:sp>
+        <p:sp>
+          <p:nvSpPr>
+            <p:cNvPr id="18" name="TextBox 18">
+              <a:extLst>
+                <a:ext uri="{FF2B5EF4-FFF2-40B4-BE49-F238E27FC236}">
+                  <a16:creationId xmlns:a16="http://schemas.microsoft.com/office/drawing/2014/main" id="{077959A1-7605-DEE0-8EED-5C1AB003A2E8}"/>
+                </a:ext>
+              </a:extLst>
+            </p:cNvPr>
+            <p:cNvSpPr txBox="1"/>
+            <p:nvPr/>
+          </p:nvSpPr>
+          <p:spPr>
+            <a:xfrm>
+              <a:off x="76200" y="38100"/>
+              <a:ext cx="660400" cy="698500"/>
+            </a:xfrm>
+            <a:prstGeom prst="rect">
+              <a:avLst/>
+            </a:prstGeom>
+          </p:spPr>
+          <p:txBody>
+            <a:bodyPr lIns="50800" tIns="50800" rIns="50800" bIns="50800" rtlCol="0" anchor="ctr"/>
+            <a:lstStyle/>
+            <a:p>
+              <a:pPr marL="0" lvl="0" indent="0" algn="ctr">
+                <a:lnSpc>
+                  <a:spcPts val="2659"/>
+                </a:lnSpc>
+                <a:spcBef>
+                  <a:spcPct val="0"/>
+                </a:spcBef>
+              </a:pPr>
+              <a:endParaRPr/>
+            </a:p>
+          </p:txBody>
+        </p:sp>
+      </p:grpSp>
+      <p:grpSp>
+        <p:nvGrpSpPr>
+          <p:cNvPr id="19" name="Group 19">
+            <a:extLst>
+              <a:ext uri="{FF2B5EF4-FFF2-40B4-BE49-F238E27FC236}">
+                <a16:creationId xmlns:a16="http://schemas.microsoft.com/office/drawing/2014/main" id="{4A0C4713-A045-9D2E-1166-50BE0035FF46}"/>
+              </a:ext>
+            </a:extLst>
+          </p:cNvPr>
+          <p:cNvGrpSpPr/>
+          <p:nvPr/>
+        </p:nvGrpSpPr>
+        <p:grpSpPr>
+          <a:xfrm>
+            <a:off x="15791221" y="2031709"/>
+            <a:ext cx="344610" cy="344610"/>
+            <a:chOff x="0" y="0"/>
+            <a:chExt cx="812800" cy="812800"/>
+          </a:xfrm>
+        </p:grpSpPr>
+        <p:sp>
+          <p:nvSpPr>
+            <p:cNvPr id="20" name="Freeform 20">
+              <a:extLst>
+                <a:ext uri="{FF2B5EF4-FFF2-40B4-BE49-F238E27FC236}">
+                  <a16:creationId xmlns:a16="http://schemas.microsoft.com/office/drawing/2014/main" id="{6BE08024-E801-1E28-2C62-1A01B5F6712E}"/>
+                </a:ext>
+              </a:extLst>
+            </p:cNvPr>
+            <p:cNvSpPr/>
+            <p:nvPr/>
+          </p:nvSpPr>
+          <p:spPr>
+            <a:xfrm>
+              <a:off x="0" y="0"/>
+              <a:ext cx="812800" cy="812800"/>
+            </a:xfrm>
+            <a:custGeom>
+              <a:avLst/>
+              <a:gdLst/>
+              <a:ahLst/>
+              <a:cxnLst/>
+              <a:rect l="l" t="t" r="r" b="b"/>
+              <a:pathLst>
+                <a:path w="812800" h="812800">
+                  <a:moveTo>
+                    <a:pt x="406400" y="0"/>
+                  </a:moveTo>
+                  <a:cubicBezTo>
+                    <a:pt x="181951" y="0"/>
+                    <a:pt x="0" y="181951"/>
+                    <a:pt x="0" y="406400"/>
+                  </a:cubicBezTo>
+                  <a:cubicBezTo>
+                    <a:pt x="0" y="630849"/>
+                    <a:pt x="181951" y="812800"/>
+                    <a:pt x="406400" y="812800"/>
+                  </a:cubicBezTo>
+                  <a:cubicBezTo>
+                    <a:pt x="630849" y="812800"/>
+                    <a:pt x="812800" y="630849"/>
+                    <a:pt x="812800" y="406400"/>
+                  </a:cubicBezTo>
+                  <a:cubicBezTo>
+                    <a:pt x="812800" y="181951"/>
+                    <a:pt x="630849" y="0"/>
+                    <a:pt x="406400" y="0"/>
+                  </a:cubicBezTo>
+                  <a:close/>
+                </a:path>
+              </a:pathLst>
+            </a:custGeom>
+            <a:gradFill rotWithShape="1">
+              <a:gsLst>
+                <a:gs pos="0">
+                  <a:srgbClr val="0151B8">
+                    <a:alpha val="100000"/>
+                  </a:srgbClr>
+                </a:gs>
+                <a:gs pos="100000">
+                  <a:srgbClr val="0151B8">
+                    <a:alpha val="24000"/>
+                  </a:srgbClr>
+                </a:gs>
+              </a:gsLst>
+              <a:lin ang="0"/>
+            </a:gradFill>
+            <a:ln cap="sq">
+              <a:noFill/>
+              <a:prstDash val="solid"/>
+              <a:miter/>
+            </a:ln>
+          </p:spPr>
+          <p:txBody>
+            <a:bodyPr/>
+            <a:lstStyle/>
+            <a:p>
+              <a:endParaRPr lang="en-US"/>
+            </a:p>
+          </p:txBody>
+        </p:sp>
+        <p:sp>
+          <p:nvSpPr>
+            <p:cNvPr id="21" name="TextBox 21">
+              <a:extLst>
+                <a:ext uri="{FF2B5EF4-FFF2-40B4-BE49-F238E27FC236}">
+                  <a16:creationId xmlns:a16="http://schemas.microsoft.com/office/drawing/2014/main" id="{D6521EA1-56D1-F721-2F9F-845E185B5E01}"/>
+                </a:ext>
+              </a:extLst>
+            </p:cNvPr>
+            <p:cNvSpPr txBox="1"/>
+            <p:nvPr/>
+          </p:nvSpPr>
+          <p:spPr>
+            <a:xfrm>
+              <a:off x="76200" y="38100"/>
+              <a:ext cx="660400" cy="698500"/>
+            </a:xfrm>
+            <a:prstGeom prst="rect">
+              <a:avLst/>
+            </a:prstGeom>
+          </p:spPr>
+          <p:txBody>
+            <a:bodyPr lIns="50800" tIns="50800" rIns="50800" bIns="50800" rtlCol="0" anchor="ctr"/>
+            <a:lstStyle/>
+            <a:p>
+              <a:pPr marL="0" lvl="0" indent="0" algn="ctr">
+                <a:lnSpc>
+                  <a:spcPts val="2659"/>
+                </a:lnSpc>
+                <a:spcBef>
+                  <a:spcPct val="0"/>
+                </a:spcBef>
+              </a:pPr>
+              <a:endParaRPr/>
+            </a:p>
+          </p:txBody>
+        </p:sp>
+      </p:grpSp>
+      <p:grpSp>
+        <p:nvGrpSpPr>
+          <p:cNvPr id="22" name="Group 22">
+            <a:extLst>
+              <a:ext uri="{FF2B5EF4-FFF2-40B4-BE49-F238E27FC236}">
+                <a16:creationId xmlns:a16="http://schemas.microsoft.com/office/drawing/2014/main" id="{EA19BB1E-B1DA-2103-C3C7-90C6E7795A89}"/>
+              </a:ext>
+            </a:extLst>
+          </p:cNvPr>
+          <p:cNvGrpSpPr/>
+          <p:nvPr/>
+        </p:nvGrpSpPr>
+        <p:grpSpPr>
+          <a:xfrm>
+            <a:off x="2363892" y="8024847"/>
+            <a:ext cx="344610" cy="344610"/>
+            <a:chOff x="0" y="0"/>
+            <a:chExt cx="812800" cy="812800"/>
+          </a:xfrm>
+        </p:grpSpPr>
+        <p:sp>
+          <p:nvSpPr>
+            <p:cNvPr id="23" name="Freeform 23">
+              <a:extLst>
+                <a:ext uri="{FF2B5EF4-FFF2-40B4-BE49-F238E27FC236}">
+                  <a16:creationId xmlns:a16="http://schemas.microsoft.com/office/drawing/2014/main" id="{421DCF15-CE69-941C-3B95-4F17D86AEABB}"/>
+                </a:ext>
+              </a:extLst>
+            </p:cNvPr>
+            <p:cNvSpPr/>
+            <p:nvPr/>
+          </p:nvSpPr>
+          <p:spPr>
+            <a:xfrm>
+              <a:off x="0" y="0"/>
+              <a:ext cx="812800" cy="812800"/>
+            </a:xfrm>
+            <a:custGeom>
+              <a:avLst/>
+              <a:gdLst/>
+              <a:ahLst/>
+              <a:cxnLst/>
+              <a:rect l="l" t="t" r="r" b="b"/>
+              <a:pathLst>
+                <a:path w="812800" h="812800">
+                  <a:moveTo>
+                    <a:pt x="406400" y="0"/>
+                  </a:moveTo>
+                  <a:cubicBezTo>
+                    <a:pt x="181951" y="0"/>
+                    <a:pt x="0" y="181951"/>
+                    <a:pt x="0" y="406400"/>
+                  </a:cubicBezTo>
+                  <a:cubicBezTo>
+                    <a:pt x="0" y="630849"/>
+                    <a:pt x="181951" y="812800"/>
+                    <a:pt x="406400" y="812800"/>
+                  </a:cubicBezTo>
+                  <a:cubicBezTo>
+                    <a:pt x="630849" y="812800"/>
+                    <a:pt x="812800" y="630849"/>
+                    <a:pt x="812800" y="406400"/>
+                  </a:cubicBezTo>
+                  <a:cubicBezTo>
+                    <a:pt x="812800" y="181951"/>
+                    <a:pt x="630849" y="0"/>
+                    <a:pt x="406400" y="0"/>
+                  </a:cubicBezTo>
+                  <a:close/>
+                </a:path>
+              </a:pathLst>
+            </a:custGeom>
+            <a:gradFill rotWithShape="1">
+              <a:gsLst>
+                <a:gs pos="0">
+                  <a:srgbClr val="0151B8">
+                    <a:alpha val="100000"/>
+                  </a:srgbClr>
+                </a:gs>
+                <a:gs pos="100000">
+                  <a:srgbClr val="0151B8">
+                    <a:alpha val="24000"/>
+                  </a:srgbClr>
+                </a:gs>
+              </a:gsLst>
+              <a:lin ang="0"/>
+            </a:gradFill>
+            <a:ln cap="sq">
+              <a:noFill/>
+              <a:prstDash val="solid"/>
+              <a:miter/>
+            </a:ln>
+          </p:spPr>
+          <p:txBody>
+            <a:bodyPr/>
+            <a:lstStyle/>
+            <a:p>
+              <a:endParaRPr lang="en-US"/>
+            </a:p>
+          </p:txBody>
+        </p:sp>
+        <p:sp>
+          <p:nvSpPr>
+            <p:cNvPr id="24" name="TextBox 24">
+              <a:extLst>
+                <a:ext uri="{FF2B5EF4-FFF2-40B4-BE49-F238E27FC236}">
+                  <a16:creationId xmlns:a16="http://schemas.microsoft.com/office/drawing/2014/main" id="{09E2CB6E-BC64-BEBC-8443-A8FC802A74E8}"/>
+                </a:ext>
+              </a:extLst>
+            </p:cNvPr>
+            <p:cNvSpPr txBox="1"/>
+            <p:nvPr/>
+          </p:nvSpPr>
+          <p:spPr>
+            <a:xfrm>
+              <a:off x="76200" y="38100"/>
+              <a:ext cx="660400" cy="698500"/>
+            </a:xfrm>
+            <a:prstGeom prst="rect">
+              <a:avLst/>
+            </a:prstGeom>
+          </p:spPr>
+          <p:txBody>
+            <a:bodyPr lIns="50800" tIns="50800" rIns="50800" bIns="50800" rtlCol="0" anchor="ctr"/>
+            <a:lstStyle/>
+            <a:p>
+              <a:pPr marL="0" lvl="0" indent="0" algn="ctr">
+                <a:lnSpc>
+                  <a:spcPts val="2659"/>
+                </a:lnSpc>
+                <a:spcBef>
+                  <a:spcPct val="0"/>
+                </a:spcBef>
+              </a:pPr>
+              <a:endParaRPr/>
+            </a:p>
+          </p:txBody>
+        </p:sp>
+      </p:grpSp>
+      <p:sp>
+        <p:nvSpPr>
+          <p:cNvPr id="25" name="Freeform 25">
+            <a:extLst>
+              <a:ext uri="{FF2B5EF4-FFF2-40B4-BE49-F238E27FC236}">
+                <a16:creationId xmlns:a16="http://schemas.microsoft.com/office/drawing/2014/main" id="{135CEE8A-3FD1-E697-9765-03ED9475CC42}"/>
+              </a:ext>
+            </a:extLst>
+          </p:cNvPr>
+          <p:cNvSpPr/>
+          <p:nvPr/>
+        </p:nvSpPr>
+        <p:spPr>
+          <a:xfrm>
+            <a:off x="15132008" y="5734768"/>
+            <a:ext cx="1318426" cy="710241"/>
+          </a:xfrm>
+          <a:custGeom>
+            <a:avLst/>
+            <a:gdLst/>
+            <a:ahLst/>
+            <a:cxnLst/>
+            <a:rect l="l" t="t" r="r" b="b"/>
+            <a:pathLst>
+              <a:path w="1318426" h="710241">
+                <a:moveTo>
+                  <a:pt x="0" y="0"/>
+                </a:moveTo>
+                <a:lnTo>
+                  <a:pt x="1318426" y="0"/>
+                </a:lnTo>
+                <a:lnTo>
+                  <a:pt x="1318426" y="710240"/>
+                </a:lnTo>
+                <a:lnTo>
+                  <a:pt x="0" y="710240"/>
+                </a:lnTo>
+                <a:lnTo>
+                  <a:pt x="0" y="0"/>
+                </a:lnTo>
+                <a:close/>
+              </a:path>
+            </a:pathLst>
+          </a:custGeom>
+          <a:blipFill>
+            <a:blip>
+              <a:extLst>
+                <a:ext uri="{96DAC541-7B7A-43D3-8B79-37D633B846F1}">
+                  <asvg:svgBlip xmlns:asvg="http://schemas.microsoft.com/office/drawing/2016/SVG/main" r:embed="rId2"/>
+                </a:ext>
+              </a:extLst>
+            </a:blip>
+            <a:stretch>
+              <a:fillRect b="-85630"/>
+            </a:stretch>
+          </a:blipFill>
+        </p:spPr>
+        <p:txBody>
+          <a:bodyPr/>
+          <a:lstStyle/>
+          <a:p>
+            <a:endParaRPr lang="en-US"/>
+          </a:p>
+        </p:txBody>
+      </p:sp>
+      <p:sp>
+        <p:nvSpPr>
+          <p:cNvPr id="26" name="Freeform 26">
+            <a:extLst>
+              <a:ext uri="{FF2B5EF4-FFF2-40B4-BE49-F238E27FC236}">
+                <a16:creationId xmlns:a16="http://schemas.microsoft.com/office/drawing/2014/main" id="{576B9C03-5F67-C6C6-0997-941D2BBF957D}"/>
+              </a:ext>
+            </a:extLst>
+          </p:cNvPr>
+          <p:cNvSpPr/>
+          <p:nvPr/>
+        </p:nvSpPr>
+        <p:spPr>
+          <a:xfrm>
+            <a:off x="1563092" y="5098433"/>
+            <a:ext cx="1318426" cy="710241"/>
+          </a:xfrm>
+          <a:custGeom>
+            <a:avLst/>
+            <a:gdLst/>
+            <a:ahLst/>
+            <a:cxnLst/>
+            <a:rect l="l" t="t" r="r" b="b"/>
+            <a:pathLst>
+              <a:path w="1318426" h="710241">
+                <a:moveTo>
+                  <a:pt x="0" y="0"/>
+                </a:moveTo>
+                <a:lnTo>
+                  <a:pt x="1318426" y="0"/>
+                </a:lnTo>
+                <a:lnTo>
+                  <a:pt x="1318426" y="710240"/>
+                </a:lnTo>
+                <a:lnTo>
+                  <a:pt x="0" y="710240"/>
+                </a:lnTo>
+                <a:lnTo>
+                  <a:pt x="0" y="0"/>
+                </a:lnTo>
+                <a:close/>
+              </a:path>
+            </a:pathLst>
+          </a:custGeom>
+          <a:blipFill>
+            <a:blip>
+              <a:extLst>
+                <a:ext uri="{96DAC541-7B7A-43D3-8B79-37D633B846F1}">
+                  <asvg:svgBlip xmlns:asvg="http://schemas.microsoft.com/office/drawing/2016/SVG/main" r:embed="rId2"/>
+                </a:ext>
+              </a:extLst>
+            </a:blip>
+            <a:stretch>
+              <a:fillRect b="-85630"/>
+            </a:stretch>
+          </a:blipFill>
+        </p:spPr>
+        <p:txBody>
+          <a:bodyPr/>
+          <a:lstStyle/>
+          <a:p>
+            <a:endParaRPr lang="en-US"/>
+          </a:p>
+        </p:txBody>
+      </p:sp>
+      <p:grpSp>
+        <p:nvGrpSpPr>
+          <p:cNvPr id="27" name="Group 27">
+            <a:extLst>
+              <a:ext uri="{FF2B5EF4-FFF2-40B4-BE49-F238E27FC236}">
+                <a16:creationId xmlns:a16="http://schemas.microsoft.com/office/drawing/2014/main" id="{F27E9642-528E-8584-67DB-A22F770D66A9}"/>
+              </a:ext>
+            </a:extLst>
+          </p:cNvPr>
+          <p:cNvGrpSpPr/>
+          <p:nvPr/>
+        </p:nvGrpSpPr>
+        <p:grpSpPr>
+          <a:xfrm>
+            <a:off x="349873" y="383749"/>
+            <a:ext cx="2568477" cy="740016"/>
+            <a:chOff x="0" y="0"/>
+            <a:chExt cx="676471" cy="194901"/>
+          </a:xfrm>
+        </p:grpSpPr>
+        <p:sp>
+          <p:nvSpPr>
+            <p:cNvPr id="28" name="Freeform 28">
+              <a:extLst>
+                <a:ext uri="{FF2B5EF4-FFF2-40B4-BE49-F238E27FC236}">
+                  <a16:creationId xmlns:a16="http://schemas.microsoft.com/office/drawing/2014/main" id="{83DB1237-C7DB-D63B-F367-E2ACC7824BE2}"/>
+                </a:ext>
+              </a:extLst>
+            </p:cNvPr>
+            <p:cNvSpPr/>
+            <p:nvPr/>
+          </p:nvSpPr>
+          <p:spPr>
+            <a:xfrm>
+              <a:off x="0" y="0"/>
+              <a:ext cx="676471" cy="194901"/>
+            </a:xfrm>
+            <a:custGeom>
+              <a:avLst/>
+              <a:gdLst/>
+              <a:ahLst/>
+              <a:cxnLst/>
+              <a:rect l="l" t="t" r="r" b="b"/>
+              <a:pathLst>
+                <a:path w="676471" h="194901">
+                  <a:moveTo>
+                    <a:pt x="97451" y="0"/>
+                  </a:moveTo>
+                  <a:lnTo>
+                    <a:pt x="579021" y="0"/>
+                  </a:lnTo>
+                  <a:cubicBezTo>
+                    <a:pt x="604866" y="0"/>
+                    <a:pt x="629653" y="10267"/>
+                    <a:pt x="647929" y="28543"/>
+                  </a:cubicBezTo>
+                  <a:cubicBezTo>
+                    <a:pt x="666204" y="46818"/>
+                    <a:pt x="676471" y="71605"/>
+                    <a:pt x="676471" y="97451"/>
+                  </a:cubicBezTo>
+                  <a:lnTo>
+                    <a:pt x="676471" y="97451"/>
+                  </a:lnTo>
+                  <a:cubicBezTo>
+                    <a:pt x="676471" y="151271"/>
+                    <a:pt x="632841" y="194901"/>
+                    <a:pt x="579021" y="194901"/>
+                  </a:cubicBezTo>
+                  <a:lnTo>
+                    <a:pt x="97451" y="194901"/>
+                  </a:lnTo>
+                  <a:cubicBezTo>
+                    <a:pt x="71605" y="194901"/>
+                    <a:pt x="46818" y="184634"/>
+                    <a:pt x="28543" y="166359"/>
+                  </a:cubicBezTo>
+                  <a:cubicBezTo>
+                    <a:pt x="10267" y="148083"/>
+                    <a:pt x="0" y="123296"/>
+                    <a:pt x="0" y="97451"/>
+                  </a:cubicBezTo>
+                  <a:lnTo>
+                    <a:pt x="0" y="97451"/>
+                  </a:lnTo>
+                  <a:cubicBezTo>
+                    <a:pt x="0" y="71605"/>
+                    <a:pt x="10267" y="46818"/>
+                    <a:pt x="28543" y="28543"/>
+                  </a:cubicBezTo>
+                  <a:cubicBezTo>
+                    <a:pt x="46818" y="10267"/>
+                    <a:pt x="71605" y="0"/>
+                    <a:pt x="97451" y="0"/>
+                  </a:cubicBezTo>
+                  <a:close/>
+                </a:path>
+              </a:pathLst>
+            </a:custGeom>
+            <a:gradFill rotWithShape="1">
+              <a:gsLst>
+                <a:gs pos="0">
+                  <a:srgbClr val="398DFA">
+                    <a:alpha val="60000"/>
+                  </a:srgbClr>
+                </a:gs>
+                <a:gs pos="50000">
+                  <a:srgbClr val="0151B8">
+                    <a:alpha val="14400"/>
+                  </a:srgbClr>
+                </a:gs>
+                <a:gs pos="100000">
+                  <a:srgbClr val="0151B8">
+                    <a:alpha val="0"/>
+                  </a:srgbClr>
+                </a:gs>
+              </a:gsLst>
+              <a:lin ang="0"/>
+            </a:gradFill>
+          </p:spPr>
+          <p:txBody>
+            <a:bodyPr/>
+            <a:lstStyle/>
+            <a:p>
+              <a:endParaRPr lang="en-US"/>
+            </a:p>
+          </p:txBody>
+        </p:sp>
+        <p:sp>
+          <p:nvSpPr>
+            <p:cNvPr id="29" name="TextBox 29">
+              <a:extLst>
+                <a:ext uri="{FF2B5EF4-FFF2-40B4-BE49-F238E27FC236}">
+                  <a16:creationId xmlns:a16="http://schemas.microsoft.com/office/drawing/2014/main" id="{F3EE3BD2-80DA-087A-02CE-5902794CE37C}"/>
+                </a:ext>
+              </a:extLst>
+            </p:cNvPr>
+            <p:cNvSpPr txBox="1"/>
+            <p:nvPr/>
+          </p:nvSpPr>
+          <p:spPr>
+            <a:xfrm>
+              <a:off x="0" y="-38100"/>
+              <a:ext cx="676471" cy="233001"/>
+            </a:xfrm>
+            <a:prstGeom prst="rect">
+              <a:avLst/>
+            </a:prstGeom>
+          </p:spPr>
+          <p:txBody>
+            <a:bodyPr lIns="50800" tIns="50800" rIns="50800" bIns="50800" rtlCol="0" anchor="ctr"/>
+            <a:lstStyle/>
+            <a:p>
+              <a:pPr algn="ctr">
+                <a:lnSpc>
+                  <a:spcPts val="2659"/>
+                </a:lnSpc>
+                <a:spcBef>
+                  <a:spcPct val="0"/>
+                </a:spcBef>
+              </a:pPr>
+              <a:endParaRPr/>
+            </a:p>
+          </p:txBody>
+        </p:sp>
+      </p:grpSp>
+      <p:grpSp>
+        <p:nvGrpSpPr>
+          <p:cNvPr id="30" name="Group 30">
+            <a:extLst>
+              <a:ext uri="{FF2B5EF4-FFF2-40B4-BE49-F238E27FC236}">
+                <a16:creationId xmlns:a16="http://schemas.microsoft.com/office/drawing/2014/main" id="{62164B03-BF63-BA91-1415-B6A74CA1EEF3}"/>
+              </a:ext>
+            </a:extLst>
+          </p:cNvPr>
+          <p:cNvGrpSpPr/>
+          <p:nvPr/>
+        </p:nvGrpSpPr>
+        <p:grpSpPr>
+          <a:xfrm>
+            <a:off x="14992289" y="7903458"/>
+            <a:ext cx="2568477" cy="740016"/>
+            <a:chOff x="0" y="0"/>
+            <a:chExt cx="676471" cy="194901"/>
+          </a:xfrm>
+        </p:grpSpPr>
+        <p:sp>
+          <p:nvSpPr>
+            <p:cNvPr id="31" name="Freeform 31">
+              <a:extLst>
+                <a:ext uri="{FF2B5EF4-FFF2-40B4-BE49-F238E27FC236}">
+                  <a16:creationId xmlns:a16="http://schemas.microsoft.com/office/drawing/2014/main" id="{7E08A811-103D-98FA-33E2-DE5CFFDA045A}"/>
+                </a:ext>
+              </a:extLst>
+            </p:cNvPr>
+            <p:cNvSpPr/>
+            <p:nvPr/>
+          </p:nvSpPr>
+          <p:spPr>
+            <a:xfrm>
+              <a:off x="0" y="0"/>
+              <a:ext cx="676471" cy="194901"/>
+            </a:xfrm>
+            <a:custGeom>
+              <a:avLst/>
+              <a:gdLst/>
+              <a:ahLst/>
+              <a:cxnLst/>
+              <a:rect l="l" t="t" r="r" b="b"/>
+              <a:pathLst>
+                <a:path w="676471" h="194901">
+                  <a:moveTo>
+                    <a:pt x="97451" y="0"/>
+                  </a:moveTo>
+                  <a:lnTo>
+                    <a:pt x="579021" y="0"/>
+                  </a:lnTo>
+                  <a:cubicBezTo>
+                    <a:pt x="604866" y="0"/>
+                    <a:pt x="629653" y="10267"/>
+                    <a:pt x="647929" y="28543"/>
+                  </a:cubicBezTo>
+                  <a:cubicBezTo>
+                    <a:pt x="666204" y="46818"/>
+                    <a:pt x="676471" y="71605"/>
+                    <a:pt x="676471" y="97451"/>
+                  </a:cubicBezTo>
+                  <a:lnTo>
+                    <a:pt x="676471" y="97451"/>
+                  </a:lnTo>
+                  <a:cubicBezTo>
+                    <a:pt x="676471" y="151271"/>
+                    <a:pt x="632841" y="194901"/>
+                    <a:pt x="579021" y="194901"/>
+                  </a:cubicBezTo>
+                  <a:lnTo>
+                    <a:pt x="97451" y="194901"/>
+                  </a:lnTo>
+                  <a:cubicBezTo>
+                    <a:pt x="71605" y="194901"/>
+                    <a:pt x="46818" y="184634"/>
+                    <a:pt x="28543" y="166359"/>
+                  </a:cubicBezTo>
+                  <a:cubicBezTo>
+                    <a:pt x="10267" y="148083"/>
+                    <a:pt x="0" y="123296"/>
+                    <a:pt x="0" y="97451"/>
+                  </a:cubicBezTo>
+                  <a:lnTo>
+                    <a:pt x="0" y="97451"/>
+                  </a:lnTo>
+                  <a:cubicBezTo>
+                    <a:pt x="0" y="71605"/>
+                    <a:pt x="10267" y="46818"/>
+                    <a:pt x="28543" y="28543"/>
+                  </a:cubicBezTo>
+                  <a:cubicBezTo>
+                    <a:pt x="46818" y="10267"/>
+                    <a:pt x="71605" y="0"/>
+                    <a:pt x="97451" y="0"/>
+                  </a:cubicBezTo>
+                  <a:close/>
+                </a:path>
+              </a:pathLst>
+            </a:custGeom>
+            <a:gradFill rotWithShape="1">
+              <a:gsLst>
+                <a:gs pos="0">
+                  <a:srgbClr val="398DFA">
+                    <a:alpha val="60000"/>
+                  </a:srgbClr>
+                </a:gs>
+                <a:gs pos="50000">
+                  <a:srgbClr val="0151B8">
+                    <a:alpha val="14400"/>
+                  </a:srgbClr>
+                </a:gs>
+                <a:gs pos="100000">
+                  <a:srgbClr val="0151B8">
+                    <a:alpha val="0"/>
+                  </a:srgbClr>
+                </a:gs>
+              </a:gsLst>
+              <a:lin ang="0"/>
+            </a:gradFill>
+          </p:spPr>
+          <p:txBody>
+            <a:bodyPr/>
+            <a:lstStyle/>
+            <a:p>
+              <a:endParaRPr lang="en-US"/>
+            </a:p>
+          </p:txBody>
+        </p:sp>
+        <p:sp>
+          <p:nvSpPr>
+            <p:cNvPr id="32" name="TextBox 32">
+              <a:extLst>
+                <a:ext uri="{FF2B5EF4-FFF2-40B4-BE49-F238E27FC236}">
+                  <a16:creationId xmlns:a16="http://schemas.microsoft.com/office/drawing/2014/main" id="{66949563-1438-1343-227F-0A9C3A3AFC1E}"/>
+                </a:ext>
+              </a:extLst>
+            </p:cNvPr>
+            <p:cNvSpPr txBox="1"/>
+            <p:nvPr/>
+          </p:nvSpPr>
+          <p:spPr>
+            <a:xfrm>
+              <a:off x="0" y="-38100"/>
+              <a:ext cx="676471" cy="233001"/>
+            </a:xfrm>
+            <a:prstGeom prst="rect">
+              <a:avLst/>
+            </a:prstGeom>
+          </p:spPr>
+          <p:txBody>
+            <a:bodyPr lIns="50800" tIns="50800" rIns="50800" bIns="50800" rtlCol="0" anchor="ctr"/>
+            <a:lstStyle/>
+            <a:p>
+              <a:pPr algn="ctr">
+                <a:lnSpc>
+                  <a:spcPts val="2659"/>
+                </a:lnSpc>
+                <a:spcBef>
+                  <a:spcPct val="0"/>
+                </a:spcBef>
+              </a:pPr>
+              <a:endParaRPr/>
+            </a:p>
+          </p:txBody>
+        </p:sp>
+      </p:grpSp>
+      <p:grpSp>
+        <p:nvGrpSpPr>
+          <p:cNvPr id="33" name="Group 33">
+            <a:extLst>
+              <a:ext uri="{FF2B5EF4-FFF2-40B4-BE49-F238E27FC236}">
+                <a16:creationId xmlns:a16="http://schemas.microsoft.com/office/drawing/2014/main" id="{A3A17E99-9E25-CA71-91AC-84824E696371}"/>
+              </a:ext>
+            </a:extLst>
+          </p:cNvPr>
+          <p:cNvGrpSpPr/>
+          <p:nvPr/>
+        </p:nvGrpSpPr>
+        <p:grpSpPr>
+          <a:xfrm>
+            <a:off x="-115063" y="9461658"/>
+            <a:ext cx="18518127" cy="798211"/>
+            <a:chOff x="0" y="0"/>
+            <a:chExt cx="4877202" cy="210228"/>
+          </a:xfrm>
+        </p:grpSpPr>
+        <p:sp>
+          <p:nvSpPr>
+            <p:cNvPr id="34" name="Freeform 34">
+              <a:extLst>
+                <a:ext uri="{FF2B5EF4-FFF2-40B4-BE49-F238E27FC236}">
+                  <a16:creationId xmlns:a16="http://schemas.microsoft.com/office/drawing/2014/main" id="{0FB063AD-CD9A-CB29-811E-66A8AD34FA5D}"/>
+                </a:ext>
+              </a:extLst>
+            </p:cNvPr>
+            <p:cNvSpPr/>
+            <p:nvPr/>
+          </p:nvSpPr>
+          <p:spPr>
+            <a:xfrm>
+              <a:off x="0" y="0"/>
+              <a:ext cx="4877202" cy="210228"/>
+            </a:xfrm>
+            <a:custGeom>
+              <a:avLst/>
+              <a:gdLst/>
+              <a:ahLst/>
+              <a:cxnLst/>
+              <a:rect l="l" t="t" r="r" b="b"/>
+              <a:pathLst>
+                <a:path w="4877202" h="210228">
+                  <a:moveTo>
+                    <a:pt x="0" y="0"/>
+                  </a:moveTo>
+                  <a:lnTo>
+                    <a:pt x="4877202" y="0"/>
+                  </a:lnTo>
+                  <a:lnTo>
+                    <a:pt x="4877202" y="210228"/>
+                  </a:lnTo>
+                  <a:lnTo>
+                    <a:pt x="0" y="210228"/>
+                  </a:lnTo>
+                  <a:close/>
+                </a:path>
+              </a:pathLst>
+            </a:custGeom>
+            <a:gradFill rotWithShape="1">
+              <a:gsLst>
+                <a:gs pos="0">
+                  <a:srgbClr val="0453B9">
+                    <a:alpha val="100000"/>
+                  </a:srgbClr>
+                </a:gs>
+                <a:gs pos="100000">
+                  <a:srgbClr val="3881DF">
+                    <a:alpha val="100000"/>
+                  </a:srgbClr>
+                </a:gs>
+              </a:gsLst>
+              <a:lin ang="2700000"/>
+            </a:gradFill>
+          </p:spPr>
+          <p:txBody>
+            <a:bodyPr/>
+            <a:lstStyle/>
+            <a:p>
+              <a:endParaRPr lang="en-US"/>
+            </a:p>
+          </p:txBody>
+        </p:sp>
+        <p:sp>
+          <p:nvSpPr>
+            <p:cNvPr id="35" name="TextBox 35">
+              <a:extLst>
+                <a:ext uri="{FF2B5EF4-FFF2-40B4-BE49-F238E27FC236}">
+                  <a16:creationId xmlns:a16="http://schemas.microsoft.com/office/drawing/2014/main" id="{7455C129-CE46-C132-879E-77FF48786299}"/>
+                </a:ext>
+              </a:extLst>
+            </p:cNvPr>
+            <p:cNvSpPr txBox="1"/>
+            <p:nvPr/>
+          </p:nvSpPr>
+          <p:spPr>
+            <a:xfrm>
+              <a:off x="0" y="-66675"/>
+              <a:ext cx="4877202" cy="276903"/>
+            </a:xfrm>
+            <a:prstGeom prst="rect">
+              <a:avLst/>
+            </a:prstGeom>
+          </p:spPr>
+          <p:txBody>
+            <a:bodyPr lIns="50800" tIns="50800" rIns="50800" bIns="50800" rtlCol="0" anchor="ctr"/>
+            <a:lstStyle/>
+            <a:p>
+              <a:pPr algn="ctr">
+                <a:lnSpc>
+                  <a:spcPts val="3020"/>
+                </a:lnSpc>
+              </a:pPr>
+              <a:endParaRPr/>
+            </a:p>
+          </p:txBody>
+        </p:sp>
+      </p:grpSp>
+      <p:sp>
+        <p:nvSpPr>
+          <p:cNvPr id="37" name="Slide Number Placeholder 36">
+            <a:extLst>
+              <a:ext uri="{FF2B5EF4-FFF2-40B4-BE49-F238E27FC236}">
+                <a16:creationId xmlns:a16="http://schemas.microsoft.com/office/drawing/2014/main" id="{FBA954A9-6BD6-3D63-C03D-0DB58DD4E1EF}"/>
+              </a:ext>
+            </a:extLst>
+          </p:cNvPr>
+          <p:cNvSpPr>
+            <a:spLocks noGrp="1"/>
+          </p:cNvSpPr>
+          <p:nvPr>
+            <p:ph type="sldNum" sz="quarter" idx="12"/>
+          </p:nvPr>
+        </p:nvSpPr>
+        <p:spPr/>
+        <p:txBody>
+          <a:bodyPr/>
+          <a:lstStyle/>
+          <a:p>
+            <a:fld id="{B6F15528-21DE-4FAA-801E-634DDDAF4B2B}" type="slidenum">
+              <a:rPr lang="en-US" smtClean="0"/>
+              <a:pPr/>
+              <a:t>18</a:t>
+            </a:fld>
+            <a:endParaRPr lang="en-US"/>
+          </a:p>
+        </p:txBody>
+      </p:sp>
+      <p:graphicFrame>
+        <p:nvGraphicFramePr>
+          <p:cNvPr id="38" name="Table 37">
+            <a:extLst>
+              <a:ext uri="{FF2B5EF4-FFF2-40B4-BE49-F238E27FC236}">
+                <a16:creationId xmlns:a16="http://schemas.microsoft.com/office/drawing/2014/main" id="{C3043B01-43CF-1D88-C563-16A172408C2F}"/>
+              </a:ext>
+            </a:extLst>
+          </p:cNvPr>
+          <p:cNvGraphicFramePr>
+            <a:graphicFrameLocks noGrp="1"/>
+          </p:cNvGraphicFramePr>
+          <p:nvPr>
+            <p:extLst>
+              <p:ext uri="{D42A27DB-BD31-4B8C-83A1-F6EECF244321}">
+                <p14:modId xmlns:p14="http://schemas.microsoft.com/office/powerpoint/2010/main" val="3089492577"/>
+              </p:ext>
+            </p:extLst>
+          </p:nvPr>
+        </p:nvGraphicFramePr>
+        <p:xfrm>
+          <a:off x="2774889" y="2793956"/>
+          <a:ext cx="12192000" cy="2072640"/>
+        </p:xfrm>
+        <a:graphic>
+          <a:graphicData uri="http://schemas.openxmlformats.org/drawingml/2006/table">
+            <a:tbl>
+              <a:tblPr firstRow="1" bandRow="1">
+                <a:tableStyleId>{5C22544A-7EE6-4342-B048-85BDC9FD1C3A}</a:tableStyleId>
+              </a:tblPr>
+              <a:tblGrid>
+                <a:gridCol w="4064000">
+                  <a:extLst>
+                    <a:ext uri="{9D8B030D-6E8A-4147-A177-3AD203B41FA5}">
+                      <a16:colId xmlns:a16="http://schemas.microsoft.com/office/drawing/2014/main" val="3108045442"/>
+                    </a:ext>
+                  </a:extLst>
+                </a:gridCol>
+                <a:gridCol w="4064000">
+                  <a:extLst>
+                    <a:ext uri="{9D8B030D-6E8A-4147-A177-3AD203B41FA5}">
+                      <a16:colId xmlns:a16="http://schemas.microsoft.com/office/drawing/2014/main" val="3673807653"/>
+                    </a:ext>
+                  </a:extLst>
+                </a:gridCol>
+                <a:gridCol w="4064000">
+                  <a:extLst>
+                    <a:ext uri="{9D8B030D-6E8A-4147-A177-3AD203B41FA5}">
+                      <a16:colId xmlns:a16="http://schemas.microsoft.com/office/drawing/2014/main" val="2838463495"/>
+                    </a:ext>
+                  </a:extLst>
+                </a:gridCol>
+              </a:tblGrid>
+              <a:tr h="370840">
+                <a:tc>
+                  <a:txBody>
+                    <a:bodyPr/>
+                    <a:lstStyle/>
+                    <a:p>
+                      <a:pPr algn="ctr"/>
+                      <a:r>
+                        <a:rPr lang="en-US" sz="2800"/>
+                        <a:t>MSV</a:t>
+                      </a:r>
+                    </a:p>
+                  </a:txBody>
+                  <a:tcPr/>
+                </a:tc>
+                <a:tc>
+                  <a:txBody>
+                    <a:bodyPr/>
+                    <a:lstStyle/>
+                    <a:p>
+                      <a:pPr algn="ctr"/>
+                      <a:r>
+                        <a:rPr lang="en-US" sz="2800"/>
+                        <a:t>Thành viên</a:t>
+                      </a:r>
+                    </a:p>
+                  </a:txBody>
+                  <a:tcPr/>
+                </a:tc>
+                <a:tc>
+                  <a:txBody>
+                    <a:bodyPr/>
+                    <a:lstStyle/>
+                    <a:p>
+                      <a:pPr algn="ctr"/>
+                      <a:r>
+                        <a:rPr lang="en-US" sz="2800"/>
+                        <a:t>Đóng góp (%)</a:t>
+                      </a:r>
+                    </a:p>
+                  </a:txBody>
+                  <a:tcPr/>
+                </a:tc>
+                <a:extLst>
+                  <a:ext uri="{0D108BD9-81ED-4DB2-BD59-A6C34878D82A}">
+                    <a16:rowId xmlns:a16="http://schemas.microsoft.com/office/drawing/2014/main" val="3314750342"/>
+                  </a:ext>
+                </a:extLst>
+              </a:tr>
+              <a:tr h="370840">
+                <a:tc>
+                  <a:txBody>
+                    <a:bodyPr/>
+                    <a:lstStyle/>
+                    <a:p>
+                      <a:pPr algn="ctr"/>
+                      <a:r>
+                        <a:rPr lang="en-US" sz="2800" b="0" i="0" kern="1200">
+                          <a:solidFill>
+                            <a:schemeClr val="dk1"/>
+                          </a:solidFill>
+                          <a:effectLst/>
+                          <a:latin typeface="+mn-lt"/>
+                          <a:ea typeface="+mn-ea"/>
+                          <a:cs typeface="+mn-cs"/>
+                        </a:rPr>
+                        <a:t>24021420</a:t>
+                      </a:r>
+                      <a:endParaRPr lang="en-US" sz="2800"/>
+                    </a:p>
+                  </a:txBody>
+                  <a:tcPr/>
+                </a:tc>
+                <a:tc>
+                  <a:txBody>
+                    <a:bodyPr/>
+                    <a:lstStyle/>
+                    <a:p>
+                      <a:r>
+                        <a:rPr lang="en-US" sz="2800" b="1" i="0" kern="1200">
+                          <a:solidFill>
+                            <a:schemeClr val="dk1"/>
+                          </a:solidFill>
+                          <a:effectLst/>
+                          <a:latin typeface="+mn-lt"/>
+                          <a:ea typeface="+mn-ea"/>
+                          <a:cs typeface="+mn-cs"/>
+                        </a:rPr>
+                        <a:t>Bạch Công Dũng</a:t>
+                      </a:r>
+                      <a:endParaRPr lang="en-US" sz="2800"/>
+                    </a:p>
+                  </a:txBody>
+                  <a:tcPr/>
+                </a:tc>
+                <a:tc>
+                  <a:txBody>
+                    <a:bodyPr/>
+                    <a:lstStyle/>
+                    <a:p>
+                      <a:pPr algn="ctr"/>
+                      <a:r>
+                        <a:rPr lang="en-US" sz="2800" b="0" i="0" kern="1200">
+                          <a:solidFill>
+                            <a:schemeClr val="dk1"/>
+                          </a:solidFill>
+                          <a:effectLst/>
+                          <a:latin typeface="+mn-lt"/>
+                          <a:ea typeface="+mn-ea"/>
+                          <a:cs typeface="+mn-cs"/>
+                        </a:rPr>
+                        <a:t>40</a:t>
+                      </a:r>
+                      <a:endParaRPr lang="en-US" sz="2800"/>
+                    </a:p>
+                  </a:txBody>
+                  <a:tcPr/>
+                </a:tc>
+                <a:extLst>
+                  <a:ext uri="{0D108BD9-81ED-4DB2-BD59-A6C34878D82A}">
+                    <a16:rowId xmlns:a16="http://schemas.microsoft.com/office/drawing/2014/main" val="1059397354"/>
+                  </a:ext>
+                </a:extLst>
+              </a:tr>
+              <a:tr h="370840">
+                <a:tc>
+                  <a:txBody>
+                    <a:bodyPr/>
+                    <a:lstStyle/>
+                    <a:p>
+                      <a:pPr algn="ctr"/>
+                      <a:r>
+                        <a:rPr lang="en-US" sz="2800" b="0" i="0" kern="1200">
+                          <a:solidFill>
+                            <a:schemeClr val="dk1"/>
+                          </a:solidFill>
+                          <a:effectLst/>
+                          <a:latin typeface="+mn-lt"/>
+                          <a:ea typeface="+mn-ea"/>
+                          <a:cs typeface="+mn-cs"/>
+                        </a:rPr>
+                        <a:t>24021372</a:t>
+                      </a:r>
+                      <a:endParaRPr lang="en-US" sz="2800"/>
+                    </a:p>
+                  </a:txBody>
+                  <a:tcPr/>
+                </a:tc>
+                <a:tc>
+                  <a:txBody>
+                    <a:bodyPr/>
+                    <a:lstStyle/>
+                    <a:p>
+                      <a:r>
+                        <a:rPr lang="en-US" sz="2800" b="1" i="0" kern="1200">
+                          <a:solidFill>
+                            <a:schemeClr val="dk1"/>
+                          </a:solidFill>
+                          <a:effectLst/>
+                          <a:latin typeface="+mn-lt"/>
+                          <a:ea typeface="+mn-ea"/>
+                          <a:cs typeface="+mn-cs"/>
+                        </a:rPr>
+                        <a:t>Nguyễn Văn Hoàng Anh</a:t>
+                      </a:r>
+                      <a:endParaRPr lang="en-US" sz="2800"/>
+                    </a:p>
+                  </a:txBody>
+                  <a:tcPr/>
+                </a:tc>
+                <a:tc>
+                  <a:txBody>
+                    <a:bodyPr/>
+                    <a:lstStyle/>
+                    <a:p>
+                      <a:pPr algn="ctr"/>
+                      <a:r>
+                        <a:rPr lang="en-US" sz="2800" b="0" i="0" kern="1200">
+                          <a:solidFill>
+                            <a:schemeClr val="dk1"/>
+                          </a:solidFill>
+                          <a:effectLst/>
+                          <a:latin typeface="+mn-lt"/>
+                          <a:ea typeface="+mn-ea"/>
+                          <a:cs typeface="+mn-cs"/>
+                        </a:rPr>
+                        <a:t>30</a:t>
+                      </a:r>
+                      <a:endParaRPr lang="en-US" sz="2800"/>
+                    </a:p>
+                  </a:txBody>
+                  <a:tcPr/>
+                </a:tc>
+                <a:extLst>
+                  <a:ext uri="{0D108BD9-81ED-4DB2-BD59-A6C34878D82A}">
+                    <a16:rowId xmlns:a16="http://schemas.microsoft.com/office/drawing/2014/main" val="589905670"/>
+                  </a:ext>
+                </a:extLst>
+              </a:tr>
+              <a:tr h="132080">
+                <a:tc>
+                  <a:txBody>
+                    <a:bodyPr/>
+                    <a:lstStyle/>
+                    <a:p>
+                      <a:pPr algn="ctr"/>
+                      <a:r>
+                        <a:rPr lang="en-US" sz="2800" b="0" i="0" kern="1200">
+                          <a:solidFill>
+                            <a:schemeClr val="dk1"/>
+                          </a:solidFill>
+                          <a:effectLst/>
+                          <a:latin typeface="+mn-lt"/>
+                          <a:ea typeface="+mn-ea"/>
+                          <a:cs typeface="+mn-cs"/>
+                        </a:rPr>
+                        <a:t>24021396</a:t>
+                      </a:r>
+                      <a:endParaRPr lang="en-US" sz="2800"/>
+                    </a:p>
+                  </a:txBody>
+                  <a:tcPr/>
+                </a:tc>
+                <a:tc>
+                  <a:txBody>
+                    <a:bodyPr/>
+                    <a:lstStyle/>
+                    <a:p>
+                      <a:r>
+                        <a:rPr lang="en-US" sz="2800" b="1" i="0" kern="1200">
+                          <a:solidFill>
+                            <a:schemeClr val="dk1"/>
+                          </a:solidFill>
+                          <a:effectLst/>
+                          <a:latin typeface="+mn-lt"/>
+                          <a:ea typeface="+mn-ea"/>
+                          <a:cs typeface="+mn-cs"/>
+                        </a:rPr>
+                        <a:t>Đặng Danh Công</a:t>
+                      </a:r>
+                      <a:endParaRPr lang="en-US" sz="2800"/>
+                    </a:p>
+                  </a:txBody>
+                  <a:tcPr/>
+                </a:tc>
+                <a:tc>
+                  <a:txBody>
+                    <a:bodyPr/>
+                    <a:lstStyle/>
+                    <a:p>
+                      <a:pPr algn="ctr"/>
+                      <a:r>
+                        <a:rPr lang="en-US" sz="2800" b="0" i="0" kern="1200">
+                          <a:solidFill>
+                            <a:schemeClr val="dk1"/>
+                          </a:solidFill>
+                          <a:effectLst/>
+                          <a:latin typeface="+mn-lt"/>
+                          <a:ea typeface="+mn-ea"/>
+                          <a:cs typeface="+mn-cs"/>
+                        </a:rPr>
+                        <a:t>30</a:t>
+                      </a:r>
+                      <a:endParaRPr lang="en-US" sz="2800"/>
+                    </a:p>
+                  </a:txBody>
+                  <a:tcPr/>
+                </a:tc>
+                <a:extLst>
+                  <a:ext uri="{0D108BD9-81ED-4DB2-BD59-A6C34878D82A}">
+                    <a16:rowId xmlns:a16="http://schemas.microsoft.com/office/drawing/2014/main" val="2337619160"/>
+                  </a:ext>
+                </a:extLst>
+              </a:tr>
+            </a:tbl>
+          </a:graphicData>
+        </a:graphic>
+      </p:graphicFrame>
+    </p:spTree>
+    <p:extLst>
+      <p:ext uri="{BB962C8B-B14F-4D97-AF65-F5344CB8AC3E}">
+        <p14:creationId xmlns:p14="http://schemas.microsoft.com/office/powerpoint/2010/main" val="3035997822"/>
+      </p:ext>
+    </p:extLst>
+  </p:cSld>
+  <p:clrMapOvr>
+    <a:masterClrMapping/>
+  </p:clrMapOvr>
+  <mc:AlternateContent xmlns:mc="http://schemas.openxmlformats.org/markup-compatibility/2006" xmlns:p15="http://schemas.microsoft.com/office/powerpoint/2012/main">
+    <mc:Choice Requires="p15">
+      <p:transition xmlns:p14="http://schemas.microsoft.com/office/powerpoint/2010/main" spd="slow" p14:dur="2000">
+        <p15:prstTrans prst="fallOver"/>
+      </p:transition>
+    </mc:Choice>
+    <mc:Fallback xmlns="">
+      <p:transition spd="slow">
+        <p:fade/>
+      </p:transition>
+    </mc:Fallback>
+  </mc:AlternateContent>
+</p:sld>
+</file>
+
+<file path=ppt/slides/slide19.xml><?xml version="1.0" encoding="utf-8"?>
 <p:sld xmlns:a="http://schemas.openxmlformats.org/drawingml/2006/main" xmlns:r="http://schemas.openxmlformats.org/officeDocument/2006/relationships" xmlns:p="http://schemas.openxmlformats.org/presentationml/2006/main">
   <p:cSld>
     <p:spTree>
@@ -16214,7 +18276,7 @@
             <a:fld id="{B6F15528-21DE-4FAA-801E-634DDDAF4B2B}" type="slidenum">
               <a:rPr lang="en-US" smtClean="0"/>
               <a:pPr/>
-              <a:t>18</a:t>
+              <a:t>19</a:t>
             </a:fld>
             <a:endParaRPr lang="en-US"/>
           </a:p>
@@ -16225,13 +18287,13 @@
   <p:clrMapOvr>
     <a:masterClrMapping/>
   </p:clrMapOvr>
-  <mc:AlternateContent xmlns:mc="http://schemas.openxmlformats.org/markup-compatibility/2006">
-    <mc:Choice xmlns:p15="http://schemas.microsoft.com/office/powerpoint/2012/main" Requires="p15">
+  <mc:AlternateContent xmlns:mc="http://schemas.openxmlformats.org/markup-compatibility/2006" xmlns:p15="http://schemas.microsoft.com/office/powerpoint/2012/main">
+    <mc:Choice Requires="p15">
       <p:transition xmlns:p14="http://schemas.microsoft.com/office/powerpoint/2010/main" spd="slow" p14:dur="2000">
         <p15:prstTrans prst="fallOver"/>
       </p:transition>
     </mc:Choice>
-    <mc:Fallback>
+    <mc:Fallback xmlns="">
       <p:transition spd="slow">
         <p:fade/>
       </p:transition>
@@ -24232,13 +26294,13 @@
   <p:clrMapOvr>
     <a:masterClrMapping/>
   </p:clrMapOvr>
-  <mc:AlternateContent xmlns:mc="http://schemas.openxmlformats.org/markup-compatibility/2006">
-    <mc:Choice xmlns:p159="http://schemas.microsoft.com/office/powerpoint/2015/09/main" Requires="p159">
+  <mc:AlternateContent xmlns:mc="http://schemas.openxmlformats.org/markup-compatibility/2006" xmlns:p159="http://schemas.microsoft.com/office/powerpoint/2015/09/main">
+    <mc:Choice Requires="p159">
       <p:transition xmlns:p14="http://schemas.microsoft.com/office/powerpoint/2010/main" spd="slow" p14:dur="2000">
         <p159:morph option="byObject"/>
       </p:transition>
     </mc:Choice>
-    <mc:Fallback>
+    <mc:Fallback xmlns="">
       <p:transition spd="slow">
         <p:fade/>
       </p:transition>
@@ -26733,13 +28795,13 @@
   <p:clrMapOvr>
     <a:masterClrMapping/>
   </p:clrMapOvr>
-  <mc:AlternateContent xmlns:mc="http://schemas.openxmlformats.org/markup-compatibility/2006">
-    <mc:Choice xmlns:p159="http://schemas.microsoft.com/office/powerpoint/2015/09/main" Requires="p159">
+  <mc:AlternateContent xmlns:mc="http://schemas.openxmlformats.org/markup-compatibility/2006" xmlns:p159="http://schemas.microsoft.com/office/powerpoint/2015/09/main">
+    <mc:Choice Requires="p159">
       <p:transition xmlns:p14="http://schemas.microsoft.com/office/powerpoint/2010/main" spd="slow" p14:dur="2000">
         <p159:morph option="byObject"/>
       </p:transition>
     </mc:Choice>
-    <mc:Fallback>
+    <mc:Fallback xmlns="">
       <p:transition spd="slow">
         <p:fade/>
       </p:transition>

</xml_diff>